<commit_message>
docs(demo): finalize lender deck ask slide with founder contact
Fills the previously-placeholdered contact block on the deck's "ask" slide:
Ammre Barakat, Founder · (224) 400-0531. Rebuilds the .pptx and .pdf from
build-deck.js. NMLS # still left blank (prints once issued).

Co-Authored-By: Claude Opus 4.8 <noreply@anthropic.com>
</commit_message>
<xml_diff>
--- a/demo/lender-demo/Homiquity_Lender_Demo.pptx
+++ b/demo/lender-demo/Homiquity_Lender_Demo.pptx
@@ -7909,7 +7909,7 @@
                 <a:ea typeface="Calibri" pitchFamily="34" charset="-122"/>
                 <a:cs typeface="Calibri" pitchFamily="34" charset="-120"/>
               </a:rPr>
-              <a:t>[Founder name — TODO]</a:t>
+              <a:t>Ammre Barakat, Founder</a:t>
             </a:r>
             <a:endParaRPr lang="en-US" sz="1600" dirty="0"/>
           </a:p>
@@ -7926,7 +7926,7 @@
                 <a:ea typeface="Calibri" pitchFamily="34" charset="-122"/>
                 <a:cs typeface="Calibri" pitchFamily="34" charset="-120"/>
               </a:rPr>
-              <a:t>support@homiquity.com  ·  [phone — TODO]  ·  homiquity.com</a:t>
+              <a:t>support@homiquity.com  ·  (224) 400-0531  ·  homiquity.com</a:t>
             </a:r>
             <a:endParaRPr lang="en-US" sz="1600" dirty="0"/>
           </a:p>

</xml_diff>

<commit_message>
docs(demo): finalize lender deck ask slide with founder contact (#117)
Fills the previously-placeholdered contact block on the deck's "ask" slide:
Ammre Barakat, Founder · (224) 400-0531. Rebuilds the .pptx and .pdf from
build-deck.js. NMLS # still left blank (prints once issued).

Co-authored-by: Claude Opus 4.8 <noreply@anthropic.com>
</commit_message>
<xml_diff>
--- a/demo/lender-demo/Homiquity_Lender_Demo.pptx
+++ b/demo/lender-demo/Homiquity_Lender_Demo.pptx
@@ -7909,7 +7909,7 @@
                 <a:ea typeface="Calibri" pitchFamily="34" charset="-122"/>
                 <a:cs typeface="Calibri" pitchFamily="34" charset="-120"/>
               </a:rPr>
-              <a:t>[Founder name — TODO]</a:t>
+              <a:t>Ammre Barakat, Founder</a:t>
             </a:r>
             <a:endParaRPr lang="en-US" sz="1600" dirty="0"/>
           </a:p>
@@ -7926,7 +7926,7 @@
                 <a:ea typeface="Calibri" pitchFamily="34" charset="-122"/>
                 <a:cs typeface="Calibri" pitchFamily="34" charset="-120"/>
               </a:rPr>
-              <a:t>support@homiquity.com  ·  [phone — TODO]  ·  homiquity.com</a:t>
+              <a:t>support@homiquity.com  ·  (224) 400-0531  ·  homiquity.com</a:t>
             </a:r>
             <a:endParaRPr lang="en-US" sz="1600" dirty="0"/>
           </a:p>

</xml_diff>